<commit_message>
Shorten Rutgers affiliation on website and film opening
</commit_message>
<xml_diff>
--- a/static/video/opening_public.pptx
+++ b/static/video/opening_public.pptx
@@ -3755,7 +3755,7 @@
               </a:defRPr>
             </a:pPr>
             <a:r>
-              <a:t>¹ Department of Computer Science, Rutgers University,</a:t>
+              <a:t>¹ Rutgers University</a:t>
             </a:r>
           </a:p>
         </p:txBody>
@@ -3791,7 +3791,7 @@
               </a:defRPr>
             </a:pPr>
             <a:r>
-              <a:t>08854 New Brunswick, USA.</a:t>
+              <a:t>² Indian Institute of Technology Bombay.</a:t>
             </a:r>
           </a:p>
         </p:txBody>
@@ -3799,42 +3799,6 @@
       <p:sp>
         <p:nvSpPr>
           <p:cNvPr id="10" name="TextBox 9"/>
-          <p:cNvSpPr txBox="1"/>
-          <p:nvPr/>
-        </p:nvSpPr>
-        <p:spPr>
-          <a:xfrm>
-            <a:off x="502920" y="5193792"/>
-            <a:ext cx="11186159" cy="548640"/>
-          </a:xfrm>
-          <a:prstGeom prst="rect">
-            <a:avLst/>
-          </a:prstGeom>
-          <a:noFill/>
-        </p:spPr>
-        <p:txBody>
-          <a:bodyPr wrap="none" lIns="0" rIns="0" tIns="0" bIns="0">
-            <a:spAutoFit/>
-          </a:bodyPr>
-          <a:lstStyle/>
-          <a:p>
-            <a:pPr algn="ctr">
-              <a:defRPr sz="1350" b="0">
-                <a:solidFill>
-                  <a:srgbClr val="536570"/>
-                </a:solidFill>
-                <a:latin typeface="DejaVu Sans"/>
-              </a:defRPr>
-            </a:pPr>
-            <a:r>
-              <a:t>² Indian Institute of Technology Bombay.</a:t>
-            </a:r>
-          </a:p>
-        </p:txBody>
-      </p:sp>
-      <p:sp>
-        <p:nvSpPr>
-          <p:cNvPr id="11" name="TextBox 10"/>
           <p:cNvSpPr txBox="1"/>
           <p:nvPr/>
         </p:nvSpPr>

</xml_diff>